<commit_message>
full update with all early attempts
</commit_message>
<xml_diff>
--- a/emccd_detect/docs/emccd_frame_geometry.pptx
+++ b/emccd_detect/docs/emccd_frame_geometry.pptx
@@ -212,7 +212,7 @@
           <a:p>
             <a:fld id="{C780EDF0-B220-4811-B79B-B799C93F6E92}" type="datetimeFigureOut">
               <a:rPr lang="en-US" smtClean="0"/>
-              <a:t>12/10/21</a:t>
+              <a:t>6/18/26</a:t>
             </a:fld>
             <a:endParaRPr lang="en-US"/>
           </a:p>
@@ -658,7 +658,7 @@
           <a:p>
             <a:fld id="{81E00323-19E9-4A03-9AD8-02AD30A6EE69}" type="datetime1">
               <a:rPr lang="en-US" smtClean="0"/>
-              <a:t>12/10/21</a:t>
+              <a:t>6/18/26</a:t>
             </a:fld>
             <a:endParaRPr lang="en-US"/>
           </a:p>
@@ -838,7 +838,7 @@
           <a:p>
             <a:fld id="{E5BF1A61-1F13-495E-A2D9-BABB66C9C01C}" type="datetime1">
               <a:rPr lang="en-US" smtClean="0"/>
-              <a:t>12/10/21</a:t>
+              <a:t>6/18/26</a:t>
             </a:fld>
             <a:endParaRPr lang="en-US"/>
           </a:p>
@@ -1019,7 +1019,7 @@
           <a:p>
             <a:fld id="{07F80CDF-CEAB-4920-B966-EED6DA34175C}" type="datetime1">
               <a:rPr lang="en-US" smtClean="0"/>
-              <a:t>12/10/21</a:t>
+              <a:t>6/18/26</a:t>
             </a:fld>
             <a:endParaRPr lang="en-US"/>
           </a:p>
@@ -1214,7 +1214,7 @@
           <a:p>
             <a:fld id="{EE347C18-8E5F-4503-B57B-50D58AFB2CC2}" type="datetime1">
               <a:rPr lang="en-US" smtClean="0"/>
-              <a:t>12/10/21</a:t>
+              <a:t>6/18/26</a:t>
             </a:fld>
             <a:endParaRPr lang="en-US"/>
           </a:p>
@@ -1471,7 +1471,7 @@
           <a:p>
             <a:fld id="{84DE286F-AE86-4501-968E-7FA3FB749500}" type="datetime1">
               <a:rPr lang="en-US" smtClean="0"/>
-              <a:t>12/10/21</a:t>
+              <a:t>6/18/26</a:t>
             </a:fld>
             <a:endParaRPr lang="en-US"/>
           </a:p>
@@ -1759,7 +1759,7 @@
           <a:p>
             <a:fld id="{FBA4D1BC-72E7-46E0-8893-FD248CC45C11}" type="datetime1">
               <a:rPr lang="en-US" smtClean="0"/>
-              <a:t>12/10/21</a:t>
+              <a:t>6/18/26</a:t>
             </a:fld>
             <a:endParaRPr lang="en-US"/>
           </a:p>
@@ -2181,7 +2181,7 @@
           <a:p>
             <a:fld id="{790EC9B6-11CA-45B4-AB02-BB5E959683A9}" type="datetime1">
               <a:rPr lang="en-US" smtClean="0"/>
-              <a:t>12/10/21</a:t>
+              <a:t>6/18/26</a:t>
             </a:fld>
             <a:endParaRPr lang="en-US"/>
           </a:p>
@@ -2301,7 +2301,7 @@
           <a:p>
             <a:fld id="{0B242111-65AA-4C98-B58A-72C58A998965}" type="datetime1">
               <a:rPr lang="en-US" smtClean="0"/>
-              <a:t>12/10/21</a:t>
+              <a:t>6/18/26</a:t>
             </a:fld>
             <a:endParaRPr lang="en-US"/>
           </a:p>
@@ -2399,7 +2399,7 @@
           <a:p>
             <a:fld id="{D0890A1F-558D-4264-88A3-4E8B4049623B}" type="datetime1">
               <a:rPr lang="en-US" smtClean="0"/>
-              <a:t>12/10/21</a:t>
+              <a:t>6/18/26</a:t>
             </a:fld>
             <a:endParaRPr lang="en-US"/>
           </a:p>
@@ -2677,7 +2677,7 @@
           <a:p>
             <a:fld id="{4EDA4163-FDBA-4764-A32F-5EB90F0E345E}" type="datetime1">
               <a:rPr lang="en-US" smtClean="0"/>
-              <a:t>12/10/21</a:t>
+              <a:t>6/18/26</a:t>
             </a:fld>
             <a:endParaRPr lang="en-US"/>
           </a:p>
@@ -2935,7 +2935,7 @@
           <a:p>
             <a:fld id="{B0B3128C-A531-4772-8590-B144A624372D}" type="datetime1">
               <a:rPr lang="en-US" smtClean="0"/>
-              <a:t>12/10/21</a:t>
+              <a:t>6/18/26</a:t>
             </a:fld>
             <a:endParaRPr lang="en-US"/>
           </a:p>
@@ -3149,7 +3149,7 @@
           <a:p>
             <a:fld id="{17CBE4B7-C2FA-4AD5-A578-C3445030F6EB}" type="datetime1">
               <a:rPr lang="en-US" smtClean="0"/>
-              <a:t>12/10/21</a:t>
+              <a:t>6/18/26</a:t>
             </a:fld>
             <a:endParaRPr lang="en-US"/>
           </a:p>
@@ -3562,28 +3562,6 @@
       </p:sp>
       <p:sp>
         <p:nvSpPr>
-          <p:cNvPr id="4" name="Footer Placeholder 3"/>
-          <p:cNvSpPr>
-            <a:spLocks noGrp="1"/>
-          </p:cNvSpPr>
-          <p:nvPr>
-            <p:ph type="ftr" sz="quarter" idx="11"/>
-          </p:nvPr>
-        </p:nvSpPr>
-        <p:spPr/>
-        <p:txBody>
-          <a:bodyPr/>
-          <a:lstStyle/>
-          <a:p>
-            <a:r>
-              <a:rPr lang="en-US" dirty="0"/>
-              <a:t>The technical data in this document are controlled under the U.S. Export Regulations, release to foreign persons may require an export authorization.</a:t>
-            </a:r>
-          </a:p>
-        </p:txBody>
-      </p:sp>
-      <p:sp>
-        <p:nvSpPr>
           <p:cNvPr id="5" name="Slide Number Placeholder 4"/>
           <p:cNvSpPr>
             <a:spLocks noGrp="1"/>
@@ -3783,35 +3761,6 @@
               <a:rPr lang="en-US" sz="1800" dirty="0"/>
               <a:t>is defined as the top left of the array:</a:t>
             </a:r>
-          </a:p>
-        </p:txBody>
-      </p:sp>
-      <p:sp>
-        <p:nvSpPr>
-          <p:cNvPr id="4" name="Footer Placeholder 3">
-            <a:extLst>
-              <a:ext uri="{FF2B5EF4-FFF2-40B4-BE49-F238E27FC236}">
-                <a16:creationId xmlns:a16="http://schemas.microsoft.com/office/drawing/2014/main" id="{0E9CD0EB-4AA4-1044-802E-E1BDA3F07752}"/>
-              </a:ext>
-            </a:extLst>
-          </p:cNvPr>
-          <p:cNvSpPr>
-            <a:spLocks noGrp="1"/>
-          </p:cNvSpPr>
-          <p:nvPr>
-            <p:ph type="ftr" sz="quarter" idx="11"/>
-          </p:nvPr>
-        </p:nvSpPr>
-        <p:spPr/>
-        <p:txBody>
-          <a:bodyPr/>
-          <a:lstStyle/>
-          <a:p>
-            <a:r>
-              <a:rPr lang="en-US"/>
-              <a:t>The technical data in this document are controlled under the U.S. Export Regulations, release to foreign persons may require an export authorization.</a:t>
-            </a:r>
-            <a:endParaRPr lang="en-US" dirty="0"/>
           </a:p>
         </p:txBody>
       </p:sp>
@@ -4283,35 +4232,6 @@
       </p:sp>
       <p:sp>
         <p:nvSpPr>
-          <p:cNvPr id="4" name="Footer Placeholder 3">
-            <a:extLst>
-              <a:ext uri="{FF2B5EF4-FFF2-40B4-BE49-F238E27FC236}">
-                <a16:creationId xmlns:a16="http://schemas.microsoft.com/office/drawing/2014/main" id="{65749F62-8184-8444-BD54-9E4F1BF3A894}"/>
-              </a:ext>
-            </a:extLst>
-          </p:cNvPr>
-          <p:cNvSpPr>
-            <a:spLocks noGrp="1"/>
-          </p:cNvSpPr>
-          <p:nvPr>
-            <p:ph type="ftr" sz="quarter" idx="11"/>
-          </p:nvPr>
-        </p:nvSpPr>
-        <p:spPr/>
-        <p:txBody>
-          <a:bodyPr/>
-          <a:lstStyle/>
-          <a:p>
-            <a:r>
-              <a:rPr lang="en-US"/>
-              <a:t>The technical data in this document are controlled under the U.S. Export Regulations, release to foreign persons may require an export authorization.</a:t>
-            </a:r>
-            <a:endParaRPr lang="en-US" dirty="0"/>
-          </a:p>
-        </p:txBody>
-      </p:sp>
-      <p:sp>
-        <p:nvSpPr>
           <p:cNvPr id="5" name="Slide Number Placeholder 4">
             <a:extLst>
               <a:ext uri="{FF2B5EF4-FFF2-40B4-BE49-F238E27FC236}">
@@ -4728,34 +4648,6 @@
             <a:r>
               <a:rPr lang="en-US" dirty="0"/>
               <a:t>Image Region Corners</a:t>
-            </a:r>
-          </a:p>
-        </p:txBody>
-      </p:sp>
-      <p:sp>
-        <p:nvSpPr>
-          <p:cNvPr id="4" name="Footer Placeholder 3">
-            <a:extLst>
-              <a:ext uri="{FF2B5EF4-FFF2-40B4-BE49-F238E27FC236}">
-                <a16:creationId xmlns:a16="http://schemas.microsoft.com/office/drawing/2014/main" id="{65749F62-8184-8444-BD54-9E4F1BF3A894}"/>
-              </a:ext>
-            </a:extLst>
-          </p:cNvPr>
-          <p:cNvSpPr>
-            <a:spLocks noGrp="1"/>
-          </p:cNvSpPr>
-          <p:nvPr>
-            <p:ph type="ftr" sz="quarter" idx="11"/>
-          </p:nvPr>
-        </p:nvSpPr>
-        <p:spPr/>
-        <p:txBody>
-          <a:bodyPr/>
-          <a:lstStyle/>
-          <a:p>
-            <a:r>
-              <a:rPr lang="en-US" dirty="0"/>
-              <a:t>The technical data in this document are controlled under the U.S. Export Regulations, release to foreign persons may require an export authorization.</a:t>
             </a:r>
           </a:p>
         </p:txBody>
@@ -5619,47 +5511,6 @@
           <a:noFill/>
         </p:spPr>
       </p:pic>
-      <p:sp>
-        <p:nvSpPr>
-          <p:cNvPr id="4" name="Footer Placeholder 3">
-            <a:extLst>
-              <a:ext uri="{FF2B5EF4-FFF2-40B4-BE49-F238E27FC236}">
-                <a16:creationId xmlns:a16="http://schemas.microsoft.com/office/drawing/2014/main" id="{65749F62-8184-8444-BD54-9E4F1BF3A894}"/>
-              </a:ext>
-            </a:extLst>
-          </p:cNvPr>
-          <p:cNvSpPr>
-            <a:spLocks noGrp="1"/>
-          </p:cNvSpPr>
-          <p:nvPr>
-            <p:ph type="ftr" sz="quarter" idx="11"/>
-          </p:nvPr>
-        </p:nvSpPr>
-        <p:spPr>
-          <a:xfrm>
-            <a:off x="533400" y="6356350"/>
-            <a:ext cx="7239000" cy="365125"/>
-          </a:xfrm>
-        </p:spPr>
-        <p:txBody>
-          <a:bodyPr anchor="ctr">
-            <a:normAutofit/>
-          </a:bodyPr>
-          <a:lstStyle/>
-          <a:p>
-            <a:pPr>
-              <a:spcAft>
-                <a:spcPts val="600"/>
-              </a:spcAft>
-            </a:pPr>
-            <a:r>
-              <a:rPr lang="en-US" dirty="0"/>
-              <a:t>The technical data in this document are controlled under the U.S. Export Regulations, release to foreign persons may require an export authorization.</a:t>
-            </a:r>
-            <a:endParaRPr lang="en-US"/>
-          </a:p>
-        </p:txBody>
-      </p:sp>
       <p:sp>
         <p:nvSpPr>
           <p:cNvPr id="5" name="Slide Number Placeholder 4">

</xml_diff>